<commit_message>
Quitar el seminario de Baldi y resumir el de Hopfield moderna
- Se elimina docs/09_seminario_investigacion.md y su enlace en el README.
- Diapositivas 2 y 10 de la presentacion de resultados: la actividad 6
  ahora resume el seminario sobre Ramsauer et al. (2021).

Co-Authored-By: Claude Opus 5.5 <noreply@anthropic.com>
</commit_message>
<xml_diff>
--- a/presentaciones/01_resultados_evaluacion_rna.pptx
+++ b/presentaciones/01_resultados_evaluacion_rna.pptx
@@ -1786,10 +1786,8 @@
           <a:lstStyle/>
           <a:p>
             <a:r>
-              <a:rPr lang="en-US" dirty="0"/>
-              <a:t>El seminario tiene su propia presentacion. Aqui solo el resumen.</a:t>
-            </a:r>
-            <a:endParaRPr lang="en-US" dirty="0"/>
+              <a:t>El seminario tiene su propia presentacion (03_seminario_hopfield_moderna.pptx). Aqui solo el resumen: la red moderna recupera en un paso, tolera tanto ruido como el vecino mas cercano, guarda las 26 letras y su regla de actualizacion coincide con la atencion hasta el redondeo.</a:t>
+            </a:r>
           </a:p>
         </p:txBody>
       </p:sp>
@@ -5858,7 +5856,7 @@
                 <a:ea typeface="Arial" pitchFamily="34" charset="-122"/>
                 <a:cs typeface="Arial" pitchFamily="34" charset="-120"/>
               </a:rPr>
-              <a:t>Seminario: redes profundas en física de partículas</a:t>
+              <a:t>Seminario: Hopfield Networks is All You Need</a:t>
             </a:r>
             <a:endParaRPr lang="en-US" sz="2400" dirty="0"/>
           </a:p>
@@ -5927,7 +5925,7 @@
                 <a:ea typeface="Arial" pitchFamily="34" charset="-122"/>
                 <a:cs typeface="Arial" pitchFamily="34" charset="-120"/>
               </a:rPr>
-              <a:t>Baldi, Sadowski y Whiteson (2014)</a:t>
+              <a:t>Ramsauer et al. (2021)</a:t>
             </a:r>
             <a:endParaRPr lang="en-US" sz="1250" dirty="0"/>
           </a:p>
@@ -5947,7 +5945,7 @@
                 <a:ea typeface="Arial" pitchFamily="34" charset="-122"/>
                 <a:cs typeface="Arial" pitchFamily="34" charset="-120"/>
               </a:rPr>
-              <a:t>Searching for exotic particles in high-energy physics with deep learning.</a:t>
+              <a:t>Hopfield Networks is All You Need.</a:t>
             </a:r>
             <a:endParaRPr lang="en-US" sz="1250" dirty="0"/>
           </a:p>
@@ -5967,7 +5965,7 @@
                 <a:ea typeface="Arial" pitchFamily="34" charset="-122"/>
                 <a:cs typeface="Arial" pitchFamily="34" charset="-120"/>
               </a:rPr>
-              <a:t>Nature Communications 5, 4308.</a:t>
+              <a:t>ICLR 2021. arXiv:2008.02217.</a:t>
             </a:r>
             <a:endParaRPr lang="en-US" sz="1250" dirty="0"/>
           </a:p>
@@ -5984,7 +5982,7 @@
                 <a:ea typeface="Arial" pitchFamily="34" charset="-122"/>
                 <a:cs typeface="Arial" pitchFamily="34" charset="-120"/>
               </a:rPr>
-              <a:t>Un perceptrón multicapa de 5 capas ocultas separa señal y fondo en el LHC a partir de las medidas brutas, sin variables diseñadas a mano.</a:t>
+              <a:t>Una energía log-sum-exp da a la red de Hopfield capacidad exponencial y recuperación en un paso; su regla de actualización es la atención de los Transformers. Implementada en numpy y comparada con la clásica sobre las letras de la Actividad 5.</a:t>
             </a:r>
             <a:endParaRPr lang="en-US" sz="1250" dirty="0"/>
           </a:p>
@@ -6023,7 +6021,7 @@
                 <a:ea typeface="Arial" pitchFamily="34" charset="-122"/>
                 <a:cs typeface="Arial" pitchFamily="34" charset="-120"/>
               </a:rPr>
-              <a:t>0.733 → 0.880</a:t>
+              <a:t>33 % → 79 %</a:t>
             </a:r>
             <a:endParaRPr lang="en-US" sz="3000" dirty="0"/>
           </a:p>
@@ -6062,7 +6060,7 @@
                 <a:ea typeface="Arial" pitchFamily="34" charset="-122"/>
                 <a:cs typeface="Arial" pitchFamily="34" charset="-120"/>
               </a:rPr>
-              <a:t>AUC con variables de bajo nivel: red poco profunda → profunda</a:t>
+              <a:t>letras A-D con 16 de 42 píxeles invertidos: Hopfield clásica → moderna</a:t>
             </a:r>
             <a:endParaRPr lang="en-US" sz="1100" dirty="0"/>
           </a:p>
@@ -6101,7 +6099,7 @@
                 <a:ea typeface="Arial" pitchFamily="34" charset="-122"/>
                 <a:cs typeface="Arial" pitchFamily="34" charset="-120"/>
               </a:rPr>
-              <a:t>3.7σ → 5.0σ</a:t>
+              <a:t>0 % → 100 %</a:t>
             </a:r>
             <a:endParaRPr lang="en-US" sz="3000" dirty="0"/>
           </a:p>
@@ -6140,7 +6138,7 @@
                 <a:ea typeface="Arial" pitchFamily="34" charset="-122"/>
                 <a:cs typeface="Arial" pitchFamily="34" charset="-120"/>
               </a:rPr>
-              <a:t>significancia de descubrimiento con todas las variables</a:t>
+              <a:t>alfabeto completo (26 letras) guardado y recuperado: clásica → moderna</a:t>
             </a:r>
             <a:endParaRPr lang="en-US" sz="1100" dirty="0"/>
           </a:p>
@@ -9522,7 +9520,7 @@
                 <a:ea typeface="Arial" pitchFamily="34" charset="-122"/>
                 <a:cs typeface="Arial" pitchFamily="34" charset="-120"/>
               </a:rPr>
-              <a:t>Aprendizaje profundo en física de partículas (Nature Comm. 2014)</a:t>
+              <a:t>Hopfield moderna = atención (ICLR 2021), implementada</a:t>
             </a:r>
             <a:endParaRPr lang="en-US" sz="1000" dirty="0"/>
           </a:p>

</xml_diff>